<commit_message>
Add AI-powered skill/certificate explanations and live system monitoring panel
- Integrate Google Gemini API for plain-language explanations on click
- Add ask-AI-about-me chat feature
- Add /system page with live CPU, memory, uptime, and Docker/environment stats
- Add rate limiting on AI endpoints to protect against abuse
- No new npm dependencies required (uses built-in fetch, os, fs modules)
</commit_message>
<xml_diff>
--- a/docs/Portfolio App Presentation.pptx
+++ b/docs/Portfolio App Presentation.pptx
@@ -3313,7 +3313,7 @@
                 </a:solidFill>
                 <a:latin typeface="Plus Jakarta Sans"/>
               </a:rPr>
-              <a:t>A Production-Style Full-Stack Application with AI &amp; Live DevOps Monitoring.</a:t>
+              <a:t>A Production-Grade Full-Stack Application with AI &amp; Real-Time DevOps Integration.</a:t>
             </a:r>
           </a:p>
         </p:txBody>
@@ -4089,7 +4089,7 @@
                 </a:solidFill>
                 <a:latin typeface="Plus Jakarta Sans"/>
               </a:rPr>
-              <a:t>CI Verification</a:t>
+              <a:t>Auto Deploy</a:t>
             </a:r>
           </a:p>
         </p:txBody>
@@ -4128,7 +4128,7 @@
                 </a:solidFill>
                 <a:latin typeface="Plus Jakarta Sans"/>
               </a:rPr>
-              <a:t>Uploads Docker logs when CI fails.</a:t>
+              <a:t>Triggers Vercel &amp; Render hooks.</a:t>
             </a:r>
           </a:p>
         </p:txBody>
@@ -4251,8 +4251,24 @@
           </a:bodyPr>
           <a:lstStyle/>
           <a:p>
-            <a:r>
-              <a:t>CI Pipeline (GitHub Actions)</a:t>
+            <a:pPr algn="l"/>
+            <a:r>
+              <a:rPr b="0" sz="2250" i="0" u="none">
+                <a:solidFill>
+                  <a:srgbClr val="F9FAFB"/>
+                </a:solidFill>
+                <a:latin typeface="Plus Jakarta Sans ExtraBold"/>
+              </a:rPr>
+              <a:t>CI/CD Pipeline </a:t>
+            </a:r>
+            <a:r>
+              <a:rPr b="0" sz="2250" i="0" u="none">
+                <a:solidFill>
+                  <a:srgbClr val="F9FAFB"/>
+                </a:solidFill>
+                <a:latin typeface="Plus Jakarta Sans ExtraBold"/>
+              </a:rPr>
+              <a:t>(GitHub Actions)</a:t>
             </a:r>
           </a:p>
         </p:txBody>
@@ -5800,7 +5816,7 @@
                 </a:solidFill>
                 <a:latin typeface="Plus Jakarta Sans"/>
               </a:rPr>
-              <a:t>JWT + bcrypt with HttpOnly cookie sessions.</a:t>
+              <a:t>JWT + bcrypt salting.</a:t>
             </a:r>
           </a:p>
         </p:txBody>
@@ -5898,7 +5914,7 @@
                 </a:solidFill>
                 <a:latin typeface="Plus Jakarta Sans"/>
               </a:rPr>
-              <a:t>Security headers and strict frontend origin.</a:t>
+              <a:t>Protects against XSS.</a:t>
             </a:r>
           </a:p>
         </p:txBody>
@@ -5996,7 +6012,7 @@
                 </a:solidFill>
                 <a:latin typeface="Plus Jakarta Sans"/>
               </a:rPr>
-              <a:t>Login, contact, AI limits + CSRF checks for admin mutations.</a:t>
+              <a:t>Throttles AI API calls.</a:t>
             </a:r>
           </a:p>
         </p:txBody>
@@ -6094,7 +6110,7 @@
                 </a:solidFill>
                 <a:latin typeface="Plus Jakarta Sans"/>
               </a:rPr>
-              <a:t>Real .env files and Git history excluded from release ZIPs.</a:t>
+              <a:t>Zero plaintext leaks.</a:t>
             </a:r>
           </a:p>
         </p:txBody>
@@ -7014,7 +7030,7 @@
                 </a:solidFill>
                 <a:latin typeface="Plus Jakarta Sans"/>
               </a:rPr>
-              <a:t>Production frontend target with the backend URL configured via environment variables.</a:t>
+              <a:t>Auto-deploys on push to main branch with global edge CDN distribution.</a:t>
             </a:r>
           </a:p>
         </p:txBody>
@@ -7063,69 +7079,6 @@
         <p:spPr>
           <a:xfrm>
             <a:off x="609600" y="3729037"/>
-            <a:ext cx="5210175" cy="171450"/>
-          </a:xfrm>
-          <a:prstGeom prst="rect">
-            <a:avLst/>
-          </a:prstGeom>
-          <a:noFill/>
-        </p:spPr>
-        <p:txBody>
-          <a:bodyPr wrap="square" lIns="0" rIns="0" tIns="0" bIns="0" anchor="t">
-            <a:spAutoFit/>
-          </a:bodyPr>
-          <a:lstStyle/>
-          <a:p>
-            <a:r>
-              <a:t>Node web service with /api/health checks; deploy the latest repository commit.</a:t>
-            </a:r>
-          </a:p>
-        </p:txBody>
-      </p:sp>
-      <p:sp>
-        <p:nvSpPr>
-          <p:cNvPr id="12" name="TextBox 11"/>
-          <p:cNvSpPr txBox="1"/>
-          <p:nvPr/>
-        </p:nvSpPr>
-        <p:spPr>
-          <a:xfrm>
-            <a:off x="609600" y="4243387"/>
-            <a:ext cx="5470683" cy="180975"/>
-          </a:xfrm>
-          <a:prstGeom prst="rect">
-            <a:avLst/>
-          </a:prstGeom>
-          <a:noFill/>
-        </p:spPr>
-        <p:txBody>
-          <a:bodyPr wrap="square" lIns="0" rIns="0" tIns="0" bIns="0" anchor="t">
-            <a:spAutoFit/>
-          </a:bodyPr>
-          <a:lstStyle/>
-          <a:p>
-            <a:pPr algn="l"/>
-            <a:r>
-              <a:rPr b="1" sz="1125" i="0" u="none">
-                <a:solidFill>
-                  <a:srgbClr val="34D399"/>
-                </a:solidFill>
-                <a:latin typeface="Plus Jakarta Sans"/>
-              </a:rPr>
-              <a:t>Database: TiDB Cloud</a:t>
-            </a:r>
-          </a:p>
-        </p:txBody>
-      </p:sp>
-      <p:sp>
-        <p:nvSpPr>
-          <p:cNvPr id="13" name="TextBox 12"/>
-          <p:cNvSpPr txBox="1"/>
-          <p:nvPr/>
-        </p:nvSpPr>
-        <p:spPr>
-          <a:xfrm>
-            <a:off x="609600" y="4462462"/>
             <a:ext cx="5210175" cy="171450"/>
           </a:xfrm>
           <a:prstGeom prst="rect">
@@ -7151,7 +7104,99 @@
                 </a:solidFill>
                 <a:latin typeface="Plus Jakarta Sans"/>
               </a:rPr>
-              <a:t>MySQL-compatible database with TLS and connection pooling.</a:t>
+              <a:t>Node web service with automated health checks at </a:t>
+            </a:r>
+            <a:r>
+              <a:rPr b="0" sz="900" i="0" u="none">
+                <a:solidFill>
+                  <a:srgbClr val="CBD5E1"/>
+                </a:solidFill>
+                <a:latin typeface="Plus Jakarta Sans"/>
+              </a:rPr>
+              <a:t>/api/health</a:t>
+            </a:r>
+            <a:r>
+              <a:rPr b="0" sz="900" i="0" u="none">
+                <a:solidFill>
+                  <a:srgbClr val="CBD5E1"/>
+                </a:solidFill>
+                <a:latin typeface="Plus Jakarta Sans"/>
+              </a:rPr>
+              <a:t>.</a:t>
+            </a:r>
+          </a:p>
+        </p:txBody>
+      </p:sp>
+      <p:sp>
+        <p:nvSpPr>
+          <p:cNvPr id="12" name="TextBox 11"/>
+          <p:cNvSpPr txBox="1"/>
+          <p:nvPr/>
+        </p:nvSpPr>
+        <p:spPr>
+          <a:xfrm>
+            <a:off x="609600" y="4243387"/>
+            <a:ext cx="5470683" cy="180975"/>
+          </a:xfrm>
+          <a:prstGeom prst="rect">
+            <a:avLst/>
+          </a:prstGeom>
+          <a:noFill/>
+        </p:spPr>
+        <p:txBody>
+          <a:bodyPr wrap="square" lIns="0" rIns="0" tIns="0" bIns="0" anchor="t">
+            <a:spAutoFit/>
+          </a:bodyPr>
+          <a:lstStyle/>
+          <a:p>
+            <a:pPr algn="l"/>
+            <a:r>
+              <a:rPr b="1" sz="1125" i="0" u="none">
+                <a:solidFill>
+                  <a:srgbClr val="34D399"/>
+                </a:solidFill>
+                <a:latin typeface="Plus Jakarta Sans"/>
+              </a:rPr>
+              <a:t>Database: TiDB Cloud</a:t>
+            </a:r>
+          </a:p>
+        </p:txBody>
+      </p:sp>
+      <p:sp>
+        <p:nvSpPr>
+          <p:cNvPr id="13" name="TextBox 12"/>
+          <p:cNvSpPr txBox="1"/>
+          <p:nvPr/>
+        </p:nvSpPr>
+        <p:spPr>
+          <a:xfrm>
+            <a:off x="609600" y="4462462"/>
+            <a:ext cx="5210175" cy="171450"/>
+          </a:xfrm>
+          <a:prstGeom prst="rect">
+            <a:avLst/>
+          </a:prstGeom>
+          <a:noFill/>
+        </p:spPr>
+        <p:txBody>
+          <a:bodyPr wrap="square" lIns="0" rIns="0" tIns="0" bIns="0" anchor="t">
+            <a:spAutoFit/>
+          </a:bodyPr>
+          <a:lstStyle/>
+          <a:p>
+            <a:pPr algn="l">
+              <a:lnSpc>
+                <a:spcPts val="1350"/>
+              </a:lnSpc>
+            </a:pPr>
+            <a:r>
+              <a:rPr b="0" sz="900" i="0" u="none">
+                <a:solidFill>
+                  <a:srgbClr val="CBD5E1"/>
+                </a:solidFill>
+                <a:latin typeface="Plus Jakarta Sans"/>
+              </a:rPr>
+              <a:t>Serverless MySQL database with auto-scaling and connection pooling.</a:t>
             </a:r>
           </a:p>
         </p:txBody>
@@ -11556,7 +11601,7 @@
                 </a:solidFill>
                 <a:latin typeface="Plus Jakarta Sans"/>
               </a:rPr>
-              <a:t>Client Layer (Vercel)</a:t>
+              <a:t>Client Layer (Vercel Edge)</a:t>
             </a:r>
           </a:p>
         </p:txBody>
@@ -12149,7 +12194,7 @@
                 </a:solidFill>
                 <a:latin typeface="Plus Jakarta Sans"/>
               </a:rPr>
-              <a:t>Projects, Skills, and Certificates are database-driven.</a:t>
+              <a:t>Projects, Skills, Experience, and Certificates are 100% database-driven.</a:t>
             </a:r>
           </a:p>
         </p:txBody>
@@ -12184,7 +12229,7 @@
                 </a:solidFill>
                 <a:latin typeface="Plus Jakarta Sans"/>
               </a:rPr>
-              <a:t>HttpOnly JWT + CSRF Admin Dashboard</a:t>
+              <a:t>JWT Admin Dashboard</a:t>
             </a:r>
           </a:p>
         </p:txBody>
@@ -12775,7 +12820,7 @@
                 </a:solidFill>
                 <a:latin typeface="Plus Jakarta Sans"/>
               </a:rPr>
-              <a:t>Per-IP throttling protects the paid AI API from abuse.</a:t>
+              <a:t>Per-IP throttling ensures 100% operational uptime.</a:t>
             </a:r>
           </a:p>
         </p:txBody>
@@ -13196,8 +13241,37 @@
           </a:bodyPr>
           <a:lstStyle/>
           <a:p>
-            <a:r>
-              <a:t>The /system page polls real live metrics from the backend every 5 seconds:</a:t>
+            <a:pPr algn="l">
+              <a:lnSpc>
+                <a:spcPts val="1575"/>
+              </a:lnSpc>
+            </a:pPr>
+            <a:r>
+              <a:rPr b="0" sz="1050" i="0" u="none">
+                <a:solidFill>
+                  <a:srgbClr val="CBD5E1"/>
+                </a:solidFill>
+                <a:latin typeface="Plus Jakarta Sans"/>
+              </a:rPr>
+              <a:t>The </a:t>
+            </a:r>
+            <a:r>
+              <a:rPr b="0" sz="1050" i="0" u="none">
+                <a:solidFill>
+                  <a:srgbClr val="38BDF8"/>
+                </a:solidFill>
+                <a:latin typeface="Plus Jakarta Sans"/>
+              </a:rPr>
+              <a:t>/system</a:t>
+            </a:r>
+            <a:r>
+              <a:rPr b="0" sz="1050" i="0" u="none">
+                <a:solidFill>
+                  <a:srgbClr val="CBD5E1"/>
+                </a:solidFill>
+                <a:latin typeface="Plus Jakarta Sans"/>
+              </a:rPr>
+              <a:t> page streams real live metrics from the host server:</a:t>
             </a:r>
           </a:p>
         </p:txBody>
@@ -13236,7 +13310,7 @@
                 </a:solidFill>
                 <a:latin typeface="Plus Jakarta Sans"/>
               </a:rPr>
-              <a:t>Terminal-style live log refreshes every 5 seconds.</a:t>
+              <a:t>Real-time terminal auto-polls every 5 seconds.</a:t>
             </a:r>
           </a:p>
         </p:txBody>

</xml_diff>